<commit_message>
analysis(AVGO): refresh post-Q2 FY26 print (June 3, 2026)
Q2 FY26 dropped today: revenue $22.2B (+48%, AI $10.8B +143%, adj EBITDA $15.2B/69%,
FCF $10.3B). Q3 guide $29.4B (+84% YoY). Stock +4.7% on the print to ~$481.62.

Key narrative refinement: Hock Tan REITERATED but did NOT raise the FY27 "AI $100B+"
guide despite the Q2 beat. Base-case haircut reduced from 24% to 15% (FY27 AI now
$85B, was $76B). Updated model, comps, deck, HTML with post-Q2 figures.

Refreshed outputs:
- DCF base implied/share: $246 -> $264 (sensitivity grid $200-311; was $185-289)
- Current price: $460 -> $482; gap: -47% -> -45%
- TTM revenue: $68.3B -> $75.5B; TTM FCF: $28.9B -> $33B+; net debt: $52B -> $49B
- Structural finding holds: market still embeds the bull AI ramp; even the
  most generous WACC/g corner ($395) is below the post-print price.

https://claude.ai/code/session_01VCX3Tmx1dtT8qoz4oxMuri
</commit_message>
<xml_diff>
--- a/analysis/AVGO/AVGO-Competitive-Analysis.pptx
+++ b/analysis/AVGO/AVGO-Competitive-Analysis.pptx
@@ -3328,7 +3328,7 @@
                 </a:solidFill>
                 <a:latin typeface="Times New Roman"/>
               </a:rPr>
-              <a:t>As of June 2026</a:t>
+              <a:t>As of June 3, 2026 (post-Q2 FY26 print)</a:t>
             </a:r>
           </a:p>
         </p:txBody>
@@ -8499,7 +8499,7 @@
                 </a:solidFill>
                 <a:latin typeface="Times New Roman"/>
               </a:rPr>
-              <a:t>• DCF base ($246) and the full WACC×g grid ($185–289) sit well below $460.</a:t>
+              <a:t>• DCF base ($264) and the full WACC×g grid ($200–311) sit well below $482.</a:t>
             </a:r>
           </a:p>
           <a:p>
@@ -8523,7 +8523,7 @@
                 </a:solidFill>
                 <a:latin typeface="Times New Roman"/>
               </a:rPr>
-              <a:t>• Comps (semis-median EV/EBITDA and fwd P/E applied to AVGO) imply ~$300–480 — AVGO already trades at/above the cohort.</a:t>
+              <a:t>• Comps (semis-median EV/EBITDA and fwd P/E applied to AVGO) imply ~$320–500 — AVGO trades at/above the cohort post-Q2.</a:t>
             </a:r>
           </a:p>
           <a:p>
@@ -8547,7 +8547,7 @@
                 </a:solidFill>
                 <a:latin typeface="Times New Roman"/>
               </a:rPr>
-              <a:t>• Only the DCF BULL case (mgmt's FY27 AI delivered) reaches into the $460 zone.</a:t>
+              <a:t>• Only the DCF BULL case (mgmt's FY27 AI fully delivered) reaches the $482 zone.</a:t>
             </a:r>
           </a:p>
           <a:p>
@@ -8571,7 +8571,7 @@
                 </a:solidFill>
                 <a:latin typeface="Times New Roman"/>
               </a:rPr>
-              <a:t>• Conclusion: at $460 the market prices the bull case as the base case.</a:t>
+              <a:t>• Conclusion: even after Q2 +48% &amp; Q3 guide +84%, the market still prices the bull case as the base case.</a:t>
             </a:r>
           </a:p>
         </p:txBody>
@@ -8702,7 +8702,7 @@
                 </a:solidFill>
                 <a:latin typeface="Times New Roman"/>
               </a:rPr>
-              <a:t>Valuation II — base-case DCF $246/share; the entire WACC × growth grid is below $460</a:t>
+              <a:t>Valuation II — base-case DCF $264/share; the entire WACC × growth grid is below $482</a:t>
             </a:r>
           </a:p>
         </p:txBody>
@@ -8742,7 +8742,7 @@
                           </a:solidFill>
                           <a:latin typeface="Times New Roman"/>
                         </a:rPr>
-                        <a:t>DCF bridge (base)</a:t>
+                        <a:t>DCF bridge (base, post-Q2 refresh)</a:t>
                       </a:r>
                     </a:p>
                   </a:txBody>
@@ -8810,7 +8810,7 @@
                           </a:solidFill>
                           <a:latin typeface="Times New Roman"/>
                         </a:rPr>
-                        <a:t>253,310</a:t>
+                        <a:t>269,084</a:t>
                       </a:r>
                     </a:p>
                   </a:txBody>
@@ -8856,7 +8856,7 @@
                           </a:solidFill>
                           <a:latin typeface="Times New Roman"/>
                         </a:rPr>
-                        <a:t>961,358</a:t>
+                        <a:t>1,030,519</a:t>
                       </a:r>
                     </a:p>
                   </a:txBody>
@@ -8902,7 +8902,7 @@
                           </a:solidFill>
                           <a:latin typeface="Times New Roman"/>
                         </a:rPr>
-                        <a:t>1,214,669</a:t>
+                        <a:t>1,299,603</a:t>
                       </a:r>
                     </a:p>
                   </a:txBody>
@@ -8948,7 +8948,7 @@
                           </a:solidFill>
                           <a:latin typeface="Times New Roman"/>
                         </a:rPr>
-                        <a:t>(51,857)</a:t>
+                        <a:t>(49,000)</a:t>
                       </a:r>
                     </a:p>
                   </a:txBody>
@@ -8994,7 +8994,7 @@
                           </a:solidFill>
                           <a:latin typeface="Times New Roman"/>
                         </a:rPr>
-                        <a:t>1,162,812</a:t>
+                        <a:t>1,250,603</a:t>
                       </a:r>
                     </a:p>
                   </a:txBody>
@@ -9086,7 +9086,7 @@
                           </a:solidFill>
                           <a:latin typeface="Times New Roman"/>
                         </a:rPr>
-                        <a:t>$245.84</a:t>
+                        <a:t>$264.40</a:t>
                       </a:r>
                     </a:p>
                   </a:txBody>
@@ -9132,7 +9132,7 @@
                           </a:solidFill>
                           <a:latin typeface="Times New Roman"/>
                         </a:rPr>
-                        <a:t>$460.00</a:t>
+                        <a:t>$481.62</a:t>
                       </a:r>
                     </a:p>
                   </a:txBody>
@@ -9178,7 +9178,7 @@
                           </a:solidFill>
                           <a:latin typeface="Times New Roman"/>
                         </a:rPr>
-                        <a:t>(46.6%)</a:t>
+                        <a:t>(45.1%)</a:t>
                       </a:r>
                     </a:p>
                   </a:txBody>
@@ -9423,7 +9423,7 @@
                           </a:solidFill>
                           <a:latin typeface="Times New Roman"/>
                         </a:rPr>
-                        <a:t>255</a:t>
+                        <a:t>275</a:t>
                       </a:r>
                     </a:p>
                   </a:txBody>
@@ -9445,7 +9445,7 @@
                           </a:solidFill>
                           <a:latin typeface="Times New Roman"/>
                         </a:rPr>
-                        <a:t>275</a:t>
+                        <a:t>296</a:t>
                       </a:r>
                     </a:p>
                   </a:txBody>
@@ -9467,7 +9467,7 @@
                           </a:solidFill>
                           <a:latin typeface="Times New Roman"/>
                         </a:rPr>
-                        <a:t>300</a:t>
+                        <a:t>323</a:t>
                       </a:r>
                     </a:p>
                   </a:txBody>
@@ -9489,7 +9489,7 @@
                           </a:solidFill>
                           <a:latin typeface="Times New Roman"/>
                         </a:rPr>
-                        <a:t>329</a:t>
+                        <a:t>355</a:t>
                       </a:r>
                     </a:p>
                   </a:txBody>
@@ -9511,7 +9511,7 @@
                           </a:solidFill>
                           <a:latin typeface="Times New Roman"/>
                         </a:rPr>
-                        <a:t>367</a:t>
+                        <a:t>395</a:t>
                       </a:r>
                     </a:p>
                   </a:txBody>
@@ -9557,7 +9557,7 @@
                           </a:solidFill>
                           <a:latin typeface="Times New Roman"/>
                         </a:rPr>
-                        <a:t>234</a:t>
+                        <a:t>252</a:t>
                       </a:r>
                     </a:p>
                   </a:txBody>
@@ -9579,7 +9579,7 @@
                           </a:solidFill>
                           <a:latin typeface="Times New Roman"/>
                         </a:rPr>
-                        <a:t>250</a:t>
+                        <a:t>270</a:t>
                       </a:r>
                     </a:p>
                   </a:txBody>
@@ -9601,7 +9601,7 @@
                           </a:solidFill>
                           <a:latin typeface="Times New Roman"/>
                         </a:rPr>
-                        <a:t>270</a:t>
+                        <a:t>291</a:t>
                       </a:r>
                     </a:p>
                   </a:txBody>
@@ -9623,7 +9623,7 @@
                           </a:solidFill>
                           <a:latin typeface="Times New Roman"/>
                         </a:rPr>
-                        <a:t>294</a:t>
+                        <a:t>317</a:t>
                       </a:r>
                     </a:p>
                   </a:txBody>
@@ -9645,7 +9645,7 @@
                           </a:solidFill>
                           <a:latin typeface="Times New Roman"/>
                         </a:rPr>
-                        <a:t>323</a:t>
+                        <a:t>348</a:t>
                       </a:r>
                     </a:p>
                   </a:txBody>
@@ -9691,7 +9691,7 @@
                           </a:solidFill>
                           <a:latin typeface="Times New Roman"/>
                         </a:rPr>
-                        <a:t>215</a:t>
+                        <a:t>232</a:t>
                       </a:r>
                     </a:p>
                   </a:txBody>
@@ -9713,7 +9713,7 @@
                           </a:solidFill>
                           <a:latin typeface="Times New Roman"/>
                         </a:rPr>
-                        <a:t>229</a:t>
+                        <a:t>247</a:t>
                       </a:r>
                     </a:p>
                   </a:txBody>
@@ -9735,7 +9735,7 @@
                           </a:solidFill>
                           <a:latin typeface="Times New Roman"/>
                         </a:rPr>
-                        <a:t>246</a:t>
+                        <a:t>265</a:t>
                       </a:r>
                     </a:p>
                   </a:txBody>
@@ -9757,7 +9757,7 @@
                           </a:solidFill>
                           <a:latin typeface="Times New Roman"/>
                         </a:rPr>
-                        <a:t>265</a:t>
+                        <a:t>286</a:t>
                       </a:r>
                     </a:p>
                   </a:txBody>
@@ -9779,7 +9779,7 @@
                           </a:solidFill>
                           <a:latin typeface="Times New Roman"/>
                         </a:rPr>
-                        <a:t>289</a:t>
+                        <a:t>311</a:t>
                       </a:r>
                     </a:p>
                   </a:txBody>
@@ -9825,7 +9825,7 @@
                           </a:solidFill>
                           <a:latin typeface="Times New Roman"/>
                         </a:rPr>
-                        <a:t>199</a:t>
+                        <a:t>215</a:t>
                       </a:r>
                     </a:p>
                   </a:txBody>
@@ -9847,7 +9847,7 @@
                           </a:solidFill>
                           <a:latin typeface="Times New Roman"/>
                         </a:rPr>
-                        <a:t>211</a:t>
+                        <a:t>228</a:t>
                       </a:r>
                     </a:p>
                   </a:txBody>
@@ -9869,7 +9869,7 @@
                           </a:solidFill>
                           <a:latin typeface="Times New Roman"/>
                         </a:rPr>
-                        <a:t>225</a:t>
+                        <a:t>243</a:t>
                       </a:r>
                     </a:p>
                   </a:txBody>
@@ -9891,7 +9891,7 @@
                           </a:solidFill>
                           <a:latin typeface="Times New Roman"/>
                         </a:rPr>
-                        <a:t>242</a:t>
+                        <a:t>260</a:t>
                       </a:r>
                     </a:p>
                   </a:txBody>
@@ -9913,7 +9913,7 @@
                           </a:solidFill>
                           <a:latin typeface="Times New Roman"/>
                         </a:rPr>
-                        <a:t>261</a:t>
+                        <a:t>281</a:t>
                       </a:r>
                     </a:p>
                   </a:txBody>
@@ -9959,7 +9959,7 @@
                           </a:solidFill>
                           <a:latin typeface="Times New Roman"/>
                         </a:rPr>
-                        <a:t>185</a:t>
+                        <a:t>200</a:t>
                       </a:r>
                     </a:p>
                   </a:txBody>
@@ -9981,7 +9981,7 @@
                           </a:solidFill>
                           <a:latin typeface="Times New Roman"/>
                         </a:rPr>
-                        <a:t>196</a:t>
+                        <a:t>211</a:t>
                       </a:r>
                     </a:p>
                   </a:txBody>
@@ -10003,7 +10003,7 @@
                           </a:solidFill>
                           <a:latin typeface="Times New Roman"/>
                         </a:rPr>
-                        <a:t>208</a:t>
+                        <a:t>224</a:t>
                       </a:r>
                     </a:p>
                   </a:txBody>
@@ -10025,7 +10025,7 @@
                           </a:solidFill>
                           <a:latin typeface="Times New Roman"/>
                         </a:rPr>
-                        <a:t>221</a:t>
+                        <a:t>239</a:t>
                       </a:r>
                     </a:p>
                   </a:txBody>
@@ -10047,7 +10047,7 @@
                           </a:solidFill>
                           <a:latin typeface="Times New Roman"/>
                         </a:rPr>
-                        <a:t>237</a:t>
+                        <a:t>256</a:t>
                       </a:r>
                     </a:p>
                   </a:txBody>
@@ -10092,7 +10092,7 @@
                 </a:solidFill>
                 <a:latin typeface="Times New Roman"/>
               </a:rPr>
-              <a:t>• Center cell ($246) = base case. Terminal value is ~79% of EV — valuation is very sensitive to WACC/g.</a:t>
+              <a:t>• Center cell ($265) = base case. Terminal value is ~79% of EV — valuation is very sensitive to WACC/g.</a:t>
             </a:r>
           </a:p>
           <a:p>
@@ -10104,7 +10104,7 @@
                 </a:solidFill>
                 <a:latin typeface="Times New Roman"/>
               </a:rPr>
-              <a:t>• Even the most generous corner (WACC 8.5% / g 4.5%) = $367 on base FCF.</a:t>
+              <a:t>• Even the most generous corner (WACC 8.5% / g 4.5%) = $395 on base FCF.</a:t>
             </a:r>
           </a:p>
           <a:p>
@@ -10116,7 +10116,7 @@
                 </a:solidFill>
                 <a:latin typeface="Times New Roman"/>
               </a:rPr>
-              <a:t>• To reach $460 you ALSO need FCF above base — i.e., mgmt's full $100B+ FY27 AI delivered (the bull case).</a:t>
+              <a:t>• To reach $482 you ALSO need FCF above base — i.e., mgmt's full $100B+ FY27 AI delivered (the bull case).</a:t>
             </a:r>
           </a:p>
         </p:txBody>
@@ -11449,7 +11449,7 @@
                           </a:solidFill>
                           <a:latin typeface="Times New Roman"/>
                         </a:rPr>
-                        <a:t>~$246 — high-quality compounder, but ~47% below the current price</a:t>
+                        <a:t>~$264 — high-quality compounder, but ~45% below the current price</a:t>
                       </a:r>
                     </a:p>
                   </a:txBody>
@@ -11750,7 +11750,7 @@
                 </a:solidFill>
                 <a:latin typeface="Times New Roman"/>
               </a:rPr>
-              <a:t>Best-in-class AI franchise — but at ~$460 the stock already prices the bull AI ramp</a:t>
+              <a:t>Q2 print confirms the franchise — but at ~$482, even after the move, the price still embeds bull AI</a:t>
             </a:r>
           </a:p>
         </p:txBody>
@@ -11820,7 +11820,7 @@
                 </a:solidFill>
                 <a:latin typeface="Times New Roman"/>
               </a:rPr>
-              <a:t>AVGO is the #1 custom AI-silicon (XPU/ASIC) design house (~70% share) plus the leading AI networking franchise (Tomahawk/Jericho). Q1 FY26: revenue $19.3B (+29%), AI revenue $8.4B (+106%), adj. EBITDA 68%. $73B AI backlog; 6 committed hyperscaler customers.</a:t>
+              <a:t>AVGO is the #1 custom AI-silicon (XPU/ASIC) design house (~70% share) + leading AI networking (Tomahawk/Jericho). Q2 FY26: revenue $22.2B (+48%), AI revenue $10.8B (+143%), adj. EBITDA $15.2B (69%), FCF $10.3B (46% margin). Q3 guide $29.4B (+84%). $73B AI backlog; 6 committed hyperscaler customers.</a:t>
             </a:r>
           </a:p>
         </p:txBody>
@@ -11890,7 +11890,7 @@
                 </a:solidFill>
                 <a:latin typeface="Times New Roman"/>
               </a:rPr>
-              <a:t>VMware turned Infrastructure Software into a $6.8B/quarter, ~78%-operating-margin annuity. Consolidated FCF ~$28.9B TTM (~42% margin). Debt down to ~$66B from a ~$74B post-VMware peak; dividend raised ~10%.</a:t>
+              <a:t>VMware turned Infrastructure Software into a ~$27B/yr, ~78%-operating-margin annuity. Consolidated TTM FCF ~$33B+ (~44% margin) after Q2's $10.3B print. Net debt down to ~$49B from a ~$74B post-VMware peak; dividend $0.65/qtr (+10%).</a:t>
             </a:r>
           </a:p>
         </p:txBody>
@@ -11960,7 +11960,7 @@
                 </a:solidFill>
                 <a:latin typeface="Times New Roman"/>
               </a:rPr>
-              <a:t>Our base-case DCF — which HAIRCUTS mgmt's '$100B+ AI in 2027' guidance ~24% for execution / OpenAI-financing risk — yields ~$246/share. The ENTIRE WACC×g sensitivity grid ($185–$289) sits below the ~$460 market price.</a:t>
+              <a:t>Hock Tan REITERATED — did NOT raise — the FY27 'AI $100B+' guide despite the Q2 beat. Our base-case DCF (now haircut ~15% to $85B FY27 AI) yields ~$264/share. The ENTIRE WACC×g grid ($200–$311) sits below the ~$482 market price; bull corner ~$395.</a:t>
             </a:r>
           </a:p>
         </p:txBody>
@@ -12030,7 +12030,7 @@
                 </a:solidFill>
                 <a:latin typeface="Times New Roman"/>
               </a:rPr>
-              <a:t>To justify $460 you need mgmt's full AI guidance delivered AND a low discount rate (the bull corner ≈ $470–520). High-quality compounder, but the margin of safety is gone at today's price. Long on pullbacks / pair vs MRVL; trim into strength.</a:t>
+              <a:t>The Q2 beat closed some of the gap (stock +4.7% on the print) — but the structural finding holds: to justify $482 you still need the full mgmt FY27 AI delivered AND a low discount rate. High-quality compounder; no margin of safety. Long on pullbacks; pair vs MRVL; trim into strength.</a:t>
             </a:r>
           </a:p>
         </p:txBody>
@@ -12065,7 +12065,7 @@
                 </a:solidFill>
                 <a:latin typeface="Times New Roman"/>
               </a:rPr>
-              <a:t>Sources: AVGO Q1 FY26 IR (Mar 2026); AVGO-Model.xlsx (base-case DCF); The Information (May 2026, OpenAI financing). Research, not investment advice.</a:t>
+              <a:t>Sources: AVGO Q2 FY26 IR (June 3, 2026); AVGO-Model.xlsx (base-case DCF); The Information (May 2026, OpenAI financing). Research, not investment advice.</a:t>
             </a:r>
           </a:p>
         </p:txBody>
@@ -12890,13 +12890,13 @@
           <a:p>
             <a:pPr algn="l"/>
             <a:r>
-              <a:rPr sz="2100" b="0" i="1">
+              <a:rPr sz="2000" b="0" i="1">
                 <a:solidFill>
                   <a:srgbClr val="17365D"/>
                 </a:solidFill>
                 <a:latin typeface="Times New Roman"/>
               </a:rPr>
-              <a:t>"Broadcom is one of the highest-quality AI franchises in the market — but at ~$460 (~31x forward earnings, ~$2.2T), how much of the AI bull case is already in the price, and what has to be true to justify owning it here?"</a:t>
+              <a:t>"Broadcom Q2 FY26 (June 3) printed +48% revenue, AI +143%, with Q3 guided +84% — but the stock is at ~$482 (~$2.3T, ~29x fwd). How much of the AI bull case is already in the price post-print, and what has to be true to justify owning it here?"</a:t>
             </a:r>
           </a:p>
         </p:txBody>
@@ -15135,7 +15135,7 @@
                           </a:solidFill>
                           <a:latin typeface="Times New Roman"/>
                         </a:rPr>
-                        <a:t>Q1 FY26 revenue</a:t>
+                        <a:t>Q1 FY26 revenue / Q2 actual</a:t>
                       </a:r>
                     </a:p>
                   </a:txBody>
@@ -15157,7 +15157,7 @@
                           </a:solidFill>
                           <a:latin typeface="Times New Roman"/>
                         </a:rPr>
-                        <a:t>$19.3B (+29% YoY)</a:t>
+                        <a:t>$19.3B (+29%) / $22.2B (+48%)</a:t>
                       </a:r>
                     </a:p>
                   </a:txBody>
@@ -15181,7 +15181,7 @@
                           </a:solidFill>
                           <a:latin typeface="Times New Roman"/>
                         </a:rPr>
-                        <a:t>Q1 FY26 AI revenue</a:t>
+                        <a:t>Q1+Q2 FY26 AI revenue</a:t>
                       </a:r>
                     </a:p>
                   </a:txBody>
@@ -15203,7 +15203,7 @@
                           </a:solidFill>
                           <a:latin typeface="Times New Roman"/>
                         </a:rPr>
-                        <a:t>$8.4B (+106% YoY)</a:t>
+                        <a:t>$8.4B + $10.8B = $19.2B (+143% Q2 YoY)</a:t>
                       </a:r>
                     </a:p>
                   </a:txBody>
@@ -15227,7 +15227,7 @@
                           </a:solidFill>
                           <a:latin typeface="Times New Roman"/>
                         </a:rPr>
-                        <a:t>Q2 FY26 guide (total / AI)</a:t>
+                        <a:t>Q3 FY26 guide (total)</a:t>
                       </a:r>
                     </a:p>
                   </a:txBody>
@@ -15249,7 +15249,7 @@
                           </a:solidFill>
                           <a:latin typeface="Times New Roman"/>
                         </a:rPr>
-                        <a:t>$22.0B / $10.7B</a:t>
+                        <a:t>$29.4B (+84%) — beat consensus $28.5B</a:t>
                       </a:r>
                     </a:p>
                   </a:txBody>
@@ -15295,7 +15295,7 @@
                           </a:solidFill>
                           <a:latin typeface="Times New Roman"/>
                         </a:rPr>
-                        <a:t>~$94.7B</a:t>
+                        <a:t>~$103-105B (raised post-Q2)</a:t>
                       </a:r>
                     </a:p>
                   </a:txBody>
@@ -15319,7 +15319,7 @@
                           </a:solidFill>
                           <a:latin typeface="Times New Roman"/>
                         </a:rPr>
-                        <a:t>Adj. EBITDA margin</a:t>
+                        <a:t>Q2 adj. EBITDA / margin</a:t>
                       </a:r>
                     </a:p>
                   </a:txBody>
@@ -15341,7 +15341,7 @@
                           </a:solidFill>
                           <a:latin typeface="Times New Roman"/>
                         </a:rPr>
-                        <a:t>68%</a:t>
+                        <a:t>$15.2B / 69%</a:t>
                       </a:r>
                     </a:p>
                   </a:txBody>
@@ -15387,7 +15387,7 @@
                           </a:solidFill>
                           <a:latin typeface="Times New Roman"/>
                         </a:rPr>
-                        <a:t>~$28.9B (~42% margin)</a:t>
+                        <a:t>~$33B+ (~44% margin); Q2 alone $10.3B</a:t>
                       </a:r>
                     </a:p>
                   </a:txBody>
@@ -15411,7 +15411,7 @@
                           </a:solidFill>
                           <a:latin typeface="Times New Roman"/>
                         </a:rPr>
-                        <a:t>Total debt / cash</a:t>
+                        <a:t>Total debt / cash [E]</a:t>
                       </a:r>
                     </a:p>
                   </a:txBody>
@@ -15433,7 +15433,7 @@
                           </a:solidFill>
                           <a:latin typeface="Times New Roman"/>
                         </a:rPr>
-                        <a:t>$66.1B / $14.2B</a:t>
+                        <a:t>~$65B / ~$16B</a:t>
                       </a:r>
                     </a:p>
                   </a:txBody>
@@ -15479,7 +15479,7 @@
                           </a:solidFill>
                           <a:latin typeface="Times New Roman"/>
                         </a:rPr>
-                        <a:t>~$51.9B</a:t>
+                        <a:t>~$49B</a:t>
                       </a:r>
                     </a:p>
                   </a:txBody>
@@ -15525,7 +15525,7 @@
                           </a:solidFill>
                           <a:latin typeface="Times New Roman"/>
                         </a:rPr>
-                        <a:t>~$2.18T / ~$2.23T</a:t>
+                        <a:t>~$2.28T / ~$2.33T</a:t>
                       </a:r>
                     </a:p>
                   </a:txBody>
@@ -15549,7 +15549,7 @@
                           </a:solidFill>
                           <a:latin typeface="Times New Roman"/>
                         </a:rPr>
-                        <a:t>P/E TTM / forward</a:t>
+                        <a:t>P/E TTM / forward [E]</a:t>
                       </a:r>
                     </a:p>
                   </a:txBody>
@@ -15571,7 +15571,7 @@
                           </a:solidFill>
                           <a:latin typeface="Times New Roman"/>
                         </a:rPr>
-                        <a:t>~80x / ~31x</a:t>
+                        <a:t>~75x / ~29x</a:t>
                       </a:r>
                     </a:p>
                   </a:txBody>
@@ -15617,7 +15617,7 @@
                           </a:solidFill>
                           <a:latin typeface="Times New Roman"/>
                         </a:rPr>
-                        <a:t>$0.65/qtr (~0.55% yield, +10%)</a:t>
+                        <a:t>$0.65/qtr (~0.54% yield, +10%)</a:t>
                       </a:r>
                     </a:p>
                   </a:txBody>

</xml_diff>